<commit_message>
Milestone 11: Implementation of Type-D elevators and small modifications.
</commit_message>
<xml_diff>
--- a/Elevator-Configuration-and-Pricing-Engine.pptx
+++ b/Elevator-Configuration-and-Pricing-Engine.pptx
@@ -5,43 +5,46 @@
     <p:sldMasterId id="2147483648" r:id="rId1"/>
   </p:sldMasterIdLst>
   <p:notesMasterIdLst>
-    <p:notesMasterId r:id="rId9"/>
+    <p:notesMasterId r:id="rId11"/>
   </p:notesMasterIdLst>
   <p:sldIdLst>
     <p:sldId id="256" r:id="rId2"/>
     <p:sldId id="257" r:id="rId3"/>
     <p:sldId id="259" r:id="rId4"/>
     <p:sldId id="260" r:id="rId5"/>
-    <p:sldId id="263" r:id="rId6"/>
-    <p:sldId id="261" r:id="rId7"/>
-    <p:sldId id="265" r:id="rId8"/>
+    <p:sldId id="266" r:id="rId6"/>
+    <p:sldId id="267" r:id="rId7"/>
+    <p:sldId id="263" r:id="rId8"/>
+    <p:sldId id="261" r:id="rId9"/>
+    <p:sldId id="265" r:id="rId10"/>
   </p:sldIdLst>
   <p:sldSz cx="9144000" cy="5143500" type="screen16x9"/>
   <p:notesSz cx="5143500" cy="9144000"/>
   <p:embeddedFontLst>
     <p:embeddedFont>
       <p:font typeface="Barlow Bold" panose="020B0604020202020204" charset="0"/>
-      <p:regular r:id="rId10"/>
+      <p:regular r:id="rId12"/>
     </p:embeddedFont>
     <p:embeddedFont>
       <p:font typeface="Barlow Light" panose="00000400000000000000" pitchFamily="2" charset="0"/>
-      <p:regular r:id="rId11"/>
-      <p:italic r:id="rId12"/>
+      <p:regular r:id="rId13"/>
+      <p:italic r:id="rId14"/>
     </p:embeddedFont>
     <p:embeddedFont>
       <p:font typeface="Montserrat" panose="00000500000000000000" pitchFamily="2" charset="0"/>
-      <p:regular r:id="rId13"/>
-      <p:bold r:id="rId14"/>
-      <p:italic r:id="rId15"/>
-      <p:boldItalic r:id="rId16"/>
+      <p:regular r:id="rId15"/>
+      <p:bold r:id="rId16"/>
+      <p:italic r:id="rId17"/>
+      <p:boldItalic r:id="rId18"/>
     </p:embeddedFont>
     <p:embeddedFont>
       <p:font typeface="Montserrat Bold" panose="00000800000000000000" charset="0"/>
-      <p:regular r:id="rId17"/>
+      <p:regular r:id="rId19"/>
     </p:embeddedFont>
     <p:embeddedFont>
       <p:font typeface="Montserrat Medium" panose="00000600000000000000" pitchFamily="2" charset="0"/>
-      <p:regular r:id="rId18"/>
+      <p:regular r:id="rId20"/>
+      <p:italic r:id="rId21"/>
     </p:embeddedFont>
   </p:embeddedFontLst>
   <p:defaultTextStyle>
@@ -670,7 +673,7 @@
           <a:p>
             <a:fld id="{F7021451-1387-4CA6-816F-3879F97B5CBC}" type="slidenum">
               <a:rPr lang="en-US"/>
-              <a:t>5</a:t>
+              <a:t>7</a:t>
             </a:fld>
             <a:endParaRPr lang="en-US"/>
           </a:p>
@@ -754,7 +757,7 @@
           <a:p>
             <a:fld id="{F7021451-1387-4CA6-816F-3879F97B5CBC}" type="slidenum">
               <a:rPr lang="en-US"/>
-              <a:t>6</a:t>
+              <a:t>8</a:t>
             </a:fld>
             <a:endParaRPr lang="en-US"/>
           </a:p>
@@ -838,7 +841,7 @@
           <a:p>
             <a:fld id="{F7021451-1387-4CA6-816F-3879F97B5CBC}" type="slidenum">
               <a:rPr lang="en-US"/>
-              <a:t>7</a:t>
+              <a:t>9</a:t>
             </a:fld>
             <a:endParaRPr lang="en-US"/>
           </a:p>
@@ -3435,24 +3438,12 @@
             <a:endParaRPr lang="en-US" sz="1200" dirty="0"/>
           </a:p>
           <a:p>
-            <a:pPr marL="101600" indent="-101600" algn="l">
+            <a:pPr algn="l">
               <a:lnSpc>
                 <a:spcPct val="100000"/>
               </a:lnSpc>
               <a:buSzPct val="100000"/>
-              <a:buChar char="•"/>
-            </a:pPr>
-            <a:r>
-              <a:rPr lang="en-US" sz="1200" dirty="0">
-                <a:solidFill>
-                  <a:srgbClr val="384653"/>
-                </a:solidFill>
-                <a:latin typeface="Montserrat" pitchFamily="34" charset="0"/>
-                <a:ea typeface="Montserrat" pitchFamily="34" charset="-122"/>
-                <a:cs typeface="Montserrat" pitchFamily="34" charset="-120"/>
-              </a:rPr>
-              <a:t>Export Services</a:t>
-            </a:r>
+            </a:pPr>
             <a:endParaRPr lang="en-US" sz="1200" dirty="0"/>
           </a:p>
         </p:txBody>
@@ -4668,7 +4659,7 @@
                 <a:ea typeface="Barlow Bold" pitchFamily="34" charset="-122"/>
                 <a:cs typeface="Barlow Bold" pitchFamily="34" charset="-120"/>
               </a:rPr>
-              <a:t>Automatic Dependency Resolution</a:t>
+              <a:t>Automatic Dependency Resolution (Type-B &amp;D)</a:t>
             </a:r>
             <a:endParaRPr lang="en-US" sz="1350" dirty="0"/>
           </a:p>
@@ -4934,7 +4925,7 @@
                 <a:ea typeface="Barlow Bold" pitchFamily="34" charset="-122"/>
                 <a:cs typeface="Barlow Bold" pitchFamily="34" charset="-120"/>
               </a:rPr>
-              <a:t>Tax Calculation</a:t>
+              <a:t>Tax &amp; Logistics Calculation</a:t>
             </a:r>
             <a:endParaRPr lang="en-US" sz="1350" dirty="0"/>
           </a:p>
@@ -5545,6 +5536,700 @@
 </file>
 
 <file path=ppt/slides/slide5.xml><?xml version="1.0" encoding="utf-8"?>
+<p:sld xmlns:a="http://schemas.openxmlformats.org/drawingml/2006/main" xmlns:r="http://schemas.openxmlformats.org/officeDocument/2006/relationships" xmlns:p="http://schemas.openxmlformats.org/presentationml/2006/main">
+  <p:cSld>
+    <p:spTree>
+      <p:nvGrpSpPr>
+        <p:cNvPr id="1" name=""/>
+        <p:cNvGrpSpPr/>
+        <p:nvPr/>
+      </p:nvGrpSpPr>
+      <p:grpSpPr>
+        <a:xfrm>
+          <a:off x="0" y="0"/>
+          <a:ext cx="0" cy="0"/>
+          <a:chOff x="0" y="0"/>
+          <a:chExt cx="0" cy="0"/>
+        </a:xfrm>
+      </p:grpSpPr>
+      <p:sp>
+        <p:nvSpPr>
+          <p:cNvPr id="3" name="Text 0">
+            <a:extLst>
+              <a:ext uri="{FF2B5EF4-FFF2-40B4-BE49-F238E27FC236}">
+                <a16:creationId xmlns:a16="http://schemas.microsoft.com/office/drawing/2014/main" id="{01E6B478-371D-F11F-C2C5-945A966A7E2F}"/>
+              </a:ext>
+            </a:extLst>
+          </p:cNvPr>
+          <p:cNvSpPr/>
+          <p:nvPr/>
+        </p:nvSpPr>
+        <p:spPr>
+          <a:xfrm>
+            <a:off x="473943" y="374005"/>
+            <a:ext cx="8196114" cy="431453"/>
+          </a:xfrm>
+          <a:prstGeom prst="rect">
+            <a:avLst/>
+          </a:prstGeom>
+          <a:noFill/>
+          <a:ln/>
+        </p:spPr>
+        <p:txBody>
+          <a:bodyPr wrap="none" lIns="0" tIns="0" rIns="0" bIns="0" rtlCol="0" anchor="t"/>
+          <a:lstStyle/>
+          <a:p>
+            <a:pPr marL="0" indent="0" algn="l">
+              <a:lnSpc>
+                <a:spcPct val="104000"/>
+              </a:lnSpc>
+              <a:buNone/>
+            </a:pPr>
+            <a:r>
+              <a:rPr lang="en-US" sz="2700" b="1" dirty="0">
+                <a:solidFill>
+                  <a:srgbClr val="2E3C4E"/>
+                </a:solidFill>
+                <a:latin typeface="Barlow Bold" pitchFamily="34" charset="0"/>
+                <a:ea typeface="Barlow Bold" pitchFamily="34" charset="-122"/>
+                <a:cs typeface="Barlow Bold" pitchFamily="34" charset="-120"/>
+              </a:rPr>
+              <a:t>Elevator categories </a:t>
+            </a:r>
+            <a:endParaRPr lang="en-US" sz="2700" dirty="0"/>
+          </a:p>
+        </p:txBody>
+      </p:sp>
+      <p:pic>
+        <p:nvPicPr>
+          <p:cNvPr id="5" name="Image 0" descr="preencoded.png">
+            <a:extLst>
+              <a:ext uri="{FF2B5EF4-FFF2-40B4-BE49-F238E27FC236}">
+                <a16:creationId xmlns:a16="http://schemas.microsoft.com/office/drawing/2014/main" id="{CD13FD48-767E-71FC-3704-D026B94187AE}"/>
+              </a:ext>
+            </a:extLst>
+          </p:cNvPr>
+          <p:cNvPicPr>
+            <a:picLocks noChangeAspect="1"/>
+          </p:cNvPicPr>
+          <p:nvPr/>
+        </p:nvPicPr>
+        <p:blipFill>
+          <a:blip>
+            <a:extLst>
+              <a:ext uri="{96DAC541-7B7A-43D3-8B79-37D633B846F1}">
+                <asvg:svgBlip xmlns:asvg="http://schemas.microsoft.com/office/drawing/2016/SVG/main" r:embed="rId2"/>
+              </a:ext>
+            </a:extLst>
+          </a:blip>
+          <a:stretch>
+            <a:fillRect/>
+          </a:stretch>
+        </p:blipFill>
+        <p:spPr>
+          <a:xfrm>
+            <a:off x="473941" y="894780"/>
+            <a:ext cx="4449751" cy="531465"/>
+          </a:xfrm>
+          <a:prstGeom prst="rect">
+            <a:avLst/>
+          </a:prstGeom>
+        </p:spPr>
+      </p:pic>
+      <p:sp>
+        <p:nvSpPr>
+          <p:cNvPr id="7" name="Text 2">
+            <a:extLst>
+              <a:ext uri="{FF2B5EF4-FFF2-40B4-BE49-F238E27FC236}">
+                <a16:creationId xmlns:a16="http://schemas.microsoft.com/office/drawing/2014/main" id="{036C0A0F-E2D1-8C90-5A24-2617C07A5DFE}"/>
+              </a:ext>
+            </a:extLst>
+          </p:cNvPr>
+          <p:cNvSpPr/>
+          <p:nvPr/>
+        </p:nvSpPr>
+        <p:spPr>
+          <a:xfrm>
+            <a:off x="613109" y="1049185"/>
+            <a:ext cx="4310584" cy="222647"/>
+          </a:xfrm>
+          <a:prstGeom prst="rect">
+            <a:avLst/>
+          </a:prstGeom>
+          <a:noFill/>
+          <a:ln/>
+        </p:spPr>
+        <p:txBody>
+          <a:bodyPr wrap="none" lIns="0" tIns="0" rIns="0" bIns="0" rtlCol="0" anchor="t"/>
+          <a:lstStyle/>
+          <a:p>
+            <a:pPr marL="0" indent="0" algn="l">
+              <a:lnSpc>
+                <a:spcPct val="104000"/>
+              </a:lnSpc>
+              <a:buNone/>
+            </a:pPr>
+            <a:r>
+              <a:rPr lang="en-US" sz="1400" b="1" dirty="0">
+                <a:solidFill>
+                  <a:srgbClr val="384653"/>
+                </a:solidFill>
+                <a:latin typeface="Barlow Bold" pitchFamily="34" charset="0"/>
+                <a:ea typeface="Barlow Bold" pitchFamily="34" charset="-122"/>
+                <a:cs typeface="Barlow Bold" pitchFamily="34" charset="-120"/>
+              </a:rPr>
+              <a:t>Type-A : Standard residential / Off the shelf elevators</a:t>
+            </a:r>
+            <a:endParaRPr lang="en-US" sz="1400" dirty="0"/>
+          </a:p>
+        </p:txBody>
+      </p:sp>
+      <p:pic>
+        <p:nvPicPr>
+          <p:cNvPr id="9" name="Image 0" descr="preencoded.png">
+            <a:extLst>
+              <a:ext uri="{FF2B5EF4-FFF2-40B4-BE49-F238E27FC236}">
+                <a16:creationId xmlns:a16="http://schemas.microsoft.com/office/drawing/2014/main" id="{0B68728D-E3EE-D57E-A080-D0441C2033FD}"/>
+              </a:ext>
+            </a:extLst>
+          </p:cNvPr>
+          <p:cNvPicPr>
+            <a:picLocks noChangeAspect="1"/>
+          </p:cNvPicPr>
+          <p:nvPr/>
+        </p:nvPicPr>
+        <p:blipFill>
+          <a:blip>
+            <a:extLst>
+              <a:ext uri="{96DAC541-7B7A-43D3-8B79-37D633B846F1}">
+                <asvg:svgBlip xmlns:asvg="http://schemas.microsoft.com/office/drawing/2016/SVG/main" r:embed="rId2"/>
+              </a:ext>
+            </a:extLst>
+          </a:blip>
+          <a:stretch>
+            <a:fillRect/>
+          </a:stretch>
+        </p:blipFill>
+        <p:spPr>
+          <a:xfrm>
+            <a:off x="485661" y="2707170"/>
+            <a:ext cx="4438031" cy="531465"/>
+          </a:xfrm>
+          <a:prstGeom prst="rect">
+            <a:avLst/>
+          </a:prstGeom>
+        </p:spPr>
+      </p:pic>
+      <p:sp>
+        <p:nvSpPr>
+          <p:cNvPr id="11" name="Text 2">
+            <a:extLst>
+              <a:ext uri="{FF2B5EF4-FFF2-40B4-BE49-F238E27FC236}">
+                <a16:creationId xmlns:a16="http://schemas.microsoft.com/office/drawing/2014/main" id="{76C4CF6A-CEE2-E59E-AB35-1A64E1858848}"/>
+              </a:ext>
+            </a:extLst>
+          </p:cNvPr>
+          <p:cNvSpPr/>
+          <p:nvPr/>
+        </p:nvSpPr>
+        <p:spPr>
+          <a:xfrm>
+            <a:off x="624830" y="2861575"/>
+            <a:ext cx="3715054" cy="222647"/>
+          </a:xfrm>
+          <a:prstGeom prst="rect">
+            <a:avLst/>
+          </a:prstGeom>
+          <a:noFill/>
+          <a:ln/>
+        </p:spPr>
+        <p:txBody>
+          <a:bodyPr wrap="none" lIns="0" tIns="0" rIns="0" bIns="0" rtlCol="0" anchor="t"/>
+          <a:lstStyle/>
+          <a:p>
+            <a:pPr marL="0" indent="0" algn="l">
+              <a:lnSpc>
+                <a:spcPct val="104000"/>
+              </a:lnSpc>
+              <a:buNone/>
+            </a:pPr>
+            <a:r>
+              <a:rPr lang="en-US" sz="1400" b="1" dirty="0">
+                <a:solidFill>
+                  <a:srgbClr val="384653"/>
+                </a:solidFill>
+                <a:latin typeface="Barlow Bold" pitchFamily="34" charset="0"/>
+                <a:ea typeface="Barlow Bold" pitchFamily="34" charset="-122"/>
+                <a:cs typeface="Barlow Bold" pitchFamily="34" charset="-120"/>
+              </a:rPr>
+              <a:t>Type-B : Commercial / Customizable elevators</a:t>
+            </a:r>
+            <a:endParaRPr lang="en-US" sz="1400" dirty="0"/>
+          </a:p>
+        </p:txBody>
+      </p:sp>
+      <p:sp>
+        <p:nvSpPr>
+          <p:cNvPr id="12" name="TextBox 11">
+            <a:extLst>
+              <a:ext uri="{FF2B5EF4-FFF2-40B4-BE49-F238E27FC236}">
+                <a16:creationId xmlns:a16="http://schemas.microsoft.com/office/drawing/2014/main" id="{DCF39005-CC45-E44E-74ED-43DEDC254ADE}"/>
+              </a:ext>
+            </a:extLst>
+          </p:cNvPr>
+          <p:cNvSpPr txBox="1"/>
+          <p:nvPr/>
+        </p:nvSpPr>
+        <p:spPr>
+          <a:xfrm>
+            <a:off x="485662" y="1568548"/>
+            <a:ext cx="8196114" cy="738664"/>
+          </a:xfrm>
+          <a:prstGeom prst="rect">
+            <a:avLst/>
+          </a:prstGeom>
+          <a:noFill/>
+        </p:spPr>
+        <p:txBody>
+          <a:bodyPr wrap="square" rtlCol="0">
+            <a:spAutoFit/>
+          </a:bodyPr>
+          <a:lstStyle/>
+          <a:p>
+            <a:pPr marL="285750" indent="-285750">
+              <a:buFont typeface="Arial" panose="020B0604020202020204" pitchFamily="34" charset="0"/>
+              <a:buChar char="•"/>
+            </a:pPr>
+            <a:r>
+              <a:rPr lang="en-IN" sz="1400" dirty="0"/>
+              <a:t>Pre-configured, cost-effective essentials with fixed capacity and speed for straightforward residential installations.</a:t>
+            </a:r>
+          </a:p>
+          <a:p>
+            <a:pPr marL="285750" indent="-285750">
+              <a:buFont typeface="Arial" panose="020B0604020202020204" pitchFamily="34" charset="0"/>
+              <a:buChar char="•"/>
+            </a:pPr>
+            <a:r>
+              <a:rPr lang="en-IN" sz="1400" dirty="0"/>
+              <a:t>Offers 5 feature classes, of which only 2 classes can be configured.</a:t>
+            </a:r>
+          </a:p>
+        </p:txBody>
+      </p:sp>
+      <p:sp>
+        <p:nvSpPr>
+          <p:cNvPr id="14" name="TextBox 13">
+            <a:extLst>
+              <a:ext uri="{FF2B5EF4-FFF2-40B4-BE49-F238E27FC236}">
+                <a16:creationId xmlns:a16="http://schemas.microsoft.com/office/drawing/2014/main" id="{CD78AC58-DE27-2061-AF17-84D6E8CE05A2}"/>
+              </a:ext>
+            </a:extLst>
+          </p:cNvPr>
+          <p:cNvSpPr txBox="1"/>
+          <p:nvPr/>
+        </p:nvSpPr>
+        <p:spPr>
+          <a:xfrm>
+            <a:off x="490349" y="3451271"/>
+            <a:ext cx="8196114" cy="954107"/>
+          </a:xfrm>
+          <a:prstGeom prst="rect">
+            <a:avLst/>
+          </a:prstGeom>
+          <a:noFill/>
+        </p:spPr>
+        <p:txBody>
+          <a:bodyPr wrap="square" rtlCol="0">
+            <a:spAutoFit/>
+          </a:bodyPr>
+          <a:lstStyle/>
+          <a:p>
+            <a:pPr marL="285750" indent="-285750">
+              <a:buFont typeface="Arial" panose="020B0604020202020204" pitchFamily="34" charset="0"/>
+              <a:buChar char="•"/>
+            </a:pPr>
+            <a:r>
+              <a:rPr lang="en-IN" sz="1400" dirty="0"/>
+              <a:t>Enhanced customization with aesthetic choices, configurable dimensions, and standard smart features for modern commercial spaces.</a:t>
+            </a:r>
+          </a:p>
+          <a:p>
+            <a:pPr marL="285750" indent="-285750">
+              <a:buFont typeface="Arial" panose="020B0604020202020204" pitchFamily="34" charset="0"/>
+              <a:buChar char="•"/>
+            </a:pPr>
+            <a:r>
+              <a:rPr lang="en-IN" sz="1400" dirty="0"/>
+              <a:t>Offers 18 customizable feature classes with 10 dependencies / constraints which is kept in check by the rule engine.</a:t>
+            </a:r>
+          </a:p>
+        </p:txBody>
+      </p:sp>
+    </p:spTree>
+    <p:extLst>
+      <p:ext uri="{BB962C8B-B14F-4D97-AF65-F5344CB8AC3E}">
+        <p14:creationId xmlns:p14="http://schemas.microsoft.com/office/powerpoint/2010/main" val="3027313289"/>
+      </p:ext>
+    </p:extLst>
+  </p:cSld>
+  <p:clrMapOvr>
+    <a:masterClrMapping/>
+  </p:clrMapOvr>
+</p:sld>
+</file>
+
+<file path=ppt/slides/slide6.xml><?xml version="1.0" encoding="utf-8"?>
+<p:sld xmlns:a="http://schemas.openxmlformats.org/drawingml/2006/main" xmlns:r="http://schemas.openxmlformats.org/officeDocument/2006/relationships" xmlns:p="http://schemas.openxmlformats.org/presentationml/2006/main">
+  <p:cSld>
+    <p:spTree>
+      <p:nvGrpSpPr>
+        <p:cNvPr id="1" name="">
+          <a:extLst>
+            <a:ext uri="{FF2B5EF4-FFF2-40B4-BE49-F238E27FC236}">
+              <a16:creationId xmlns:a16="http://schemas.microsoft.com/office/drawing/2014/main" id="{DF954286-84C2-DB80-FCE3-C50B34615AE5}"/>
+            </a:ext>
+          </a:extLst>
+        </p:cNvPr>
+        <p:cNvGrpSpPr/>
+        <p:nvPr/>
+      </p:nvGrpSpPr>
+      <p:grpSpPr>
+        <a:xfrm>
+          <a:off x="0" y="0"/>
+          <a:ext cx="0" cy="0"/>
+          <a:chOff x="0" y="0"/>
+          <a:chExt cx="0" cy="0"/>
+        </a:xfrm>
+      </p:grpSpPr>
+      <p:sp>
+        <p:nvSpPr>
+          <p:cNvPr id="3" name="Text 0">
+            <a:extLst>
+              <a:ext uri="{FF2B5EF4-FFF2-40B4-BE49-F238E27FC236}">
+                <a16:creationId xmlns:a16="http://schemas.microsoft.com/office/drawing/2014/main" id="{A6DF02F8-3CBB-09C5-C33A-08B31CB5F666}"/>
+              </a:ext>
+            </a:extLst>
+          </p:cNvPr>
+          <p:cNvSpPr/>
+          <p:nvPr/>
+        </p:nvSpPr>
+        <p:spPr>
+          <a:xfrm>
+            <a:off x="473943" y="374005"/>
+            <a:ext cx="8196114" cy="431453"/>
+          </a:xfrm>
+          <a:prstGeom prst="rect">
+            <a:avLst/>
+          </a:prstGeom>
+          <a:noFill/>
+          <a:ln/>
+        </p:spPr>
+        <p:txBody>
+          <a:bodyPr wrap="none" lIns="0" tIns="0" rIns="0" bIns="0" rtlCol="0" anchor="t"/>
+          <a:lstStyle/>
+          <a:p>
+            <a:pPr marL="0" indent="0" algn="l">
+              <a:lnSpc>
+                <a:spcPct val="104000"/>
+              </a:lnSpc>
+              <a:buNone/>
+            </a:pPr>
+            <a:r>
+              <a:rPr lang="en-US" sz="2700" b="1" dirty="0">
+                <a:solidFill>
+                  <a:srgbClr val="2E3C4E"/>
+                </a:solidFill>
+                <a:latin typeface="Barlow Bold" pitchFamily="34" charset="0"/>
+                <a:ea typeface="Barlow Bold" pitchFamily="34" charset="-122"/>
+                <a:cs typeface="Barlow Bold" pitchFamily="34" charset="-120"/>
+              </a:rPr>
+              <a:t>Elevator categories </a:t>
+            </a:r>
+            <a:endParaRPr lang="en-US" sz="2700" dirty="0"/>
+          </a:p>
+        </p:txBody>
+      </p:sp>
+      <p:pic>
+        <p:nvPicPr>
+          <p:cNvPr id="5" name="Image 0" descr="preencoded.png">
+            <a:extLst>
+              <a:ext uri="{FF2B5EF4-FFF2-40B4-BE49-F238E27FC236}">
+                <a16:creationId xmlns:a16="http://schemas.microsoft.com/office/drawing/2014/main" id="{32A018DF-35BA-1E6F-C521-33ADD329609D}"/>
+              </a:ext>
+            </a:extLst>
+          </p:cNvPr>
+          <p:cNvPicPr>
+            <a:picLocks noChangeAspect="1"/>
+          </p:cNvPicPr>
+          <p:nvPr/>
+        </p:nvPicPr>
+        <p:blipFill>
+          <a:blip>
+            <a:extLst>
+              <a:ext uri="{96DAC541-7B7A-43D3-8B79-37D633B846F1}">
+                <asvg:svgBlip xmlns:asvg="http://schemas.microsoft.com/office/drawing/2016/SVG/main" r:embed="rId2"/>
+              </a:ext>
+            </a:extLst>
+          </a:blip>
+          <a:stretch>
+            <a:fillRect/>
+          </a:stretch>
+        </p:blipFill>
+        <p:spPr>
+          <a:xfrm>
+            <a:off x="473942" y="894780"/>
+            <a:ext cx="4421616" cy="531465"/>
+          </a:xfrm>
+          <a:prstGeom prst="rect">
+            <a:avLst/>
+          </a:prstGeom>
+        </p:spPr>
+      </p:pic>
+      <p:sp>
+        <p:nvSpPr>
+          <p:cNvPr id="7" name="Text 2">
+            <a:extLst>
+              <a:ext uri="{FF2B5EF4-FFF2-40B4-BE49-F238E27FC236}">
+                <a16:creationId xmlns:a16="http://schemas.microsoft.com/office/drawing/2014/main" id="{DC06EBEA-8221-395D-B412-2AF050512BC1}"/>
+              </a:ext>
+            </a:extLst>
+          </p:cNvPr>
+          <p:cNvSpPr/>
+          <p:nvPr/>
+        </p:nvSpPr>
+        <p:spPr>
+          <a:xfrm>
+            <a:off x="613109" y="1049185"/>
+            <a:ext cx="4310584" cy="222647"/>
+          </a:xfrm>
+          <a:prstGeom prst="rect">
+            <a:avLst/>
+          </a:prstGeom>
+          <a:noFill/>
+          <a:ln/>
+        </p:spPr>
+        <p:txBody>
+          <a:bodyPr wrap="none" lIns="0" tIns="0" rIns="0" bIns="0" rtlCol="0" anchor="t"/>
+          <a:lstStyle/>
+          <a:p>
+            <a:pPr marL="0" indent="0" algn="l">
+              <a:lnSpc>
+                <a:spcPct val="104000"/>
+              </a:lnSpc>
+              <a:buNone/>
+            </a:pPr>
+            <a:r>
+              <a:rPr lang="en-US" sz="1400" b="1" dirty="0">
+                <a:solidFill>
+                  <a:srgbClr val="384653"/>
+                </a:solidFill>
+                <a:latin typeface="Barlow Bold" pitchFamily="34" charset="0"/>
+                <a:ea typeface="Barlow Bold" pitchFamily="34" charset="-122"/>
+                <a:cs typeface="Barlow Bold" pitchFamily="34" charset="-120"/>
+              </a:rPr>
+              <a:t>Type-C : Heavy Duty / Industrial elevators (Certified)</a:t>
+            </a:r>
+            <a:endParaRPr lang="en-US" sz="1400" dirty="0"/>
+          </a:p>
+        </p:txBody>
+      </p:sp>
+      <p:pic>
+        <p:nvPicPr>
+          <p:cNvPr id="9" name="Image 0" descr="preencoded.png">
+            <a:extLst>
+              <a:ext uri="{FF2B5EF4-FFF2-40B4-BE49-F238E27FC236}">
+                <a16:creationId xmlns:a16="http://schemas.microsoft.com/office/drawing/2014/main" id="{85177467-8EBF-479D-553A-F38BAC5590A6}"/>
+              </a:ext>
+            </a:extLst>
+          </p:cNvPr>
+          <p:cNvPicPr>
+            <a:picLocks noChangeAspect="1"/>
+          </p:cNvPicPr>
+          <p:nvPr/>
+        </p:nvPicPr>
+        <p:blipFill>
+          <a:blip>
+            <a:extLst>
+              <a:ext uri="{96DAC541-7B7A-43D3-8B79-37D633B846F1}">
+                <asvg:svgBlip xmlns:asvg="http://schemas.microsoft.com/office/drawing/2016/SVG/main" r:embed="rId2"/>
+              </a:ext>
+            </a:extLst>
+          </a:blip>
+          <a:stretch>
+            <a:fillRect/>
+          </a:stretch>
+        </p:blipFill>
+        <p:spPr>
+          <a:xfrm>
+            <a:off x="485661" y="2707170"/>
+            <a:ext cx="4409895" cy="531465"/>
+          </a:xfrm>
+          <a:prstGeom prst="rect">
+            <a:avLst/>
+          </a:prstGeom>
+        </p:spPr>
+      </p:pic>
+      <p:sp>
+        <p:nvSpPr>
+          <p:cNvPr id="11" name="Text 2">
+            <a:extLst>
+              <a:ext uri="{FF2B5EF4-FFF2-40B4-BE49-F238E27FC236}">
+                <a16:creationId xmlns:a16="http://schemas.microsoft.com/office/drawing/2014/main" id="{33DDE3A4-3662-3F78-8809-AE26C1348B77}"/>
+              </a:ext>
+            </a:extLst>
+          </p:cNvPr>
+          <p:cNvSpPr/>
+          <p:nvPr/>
+        </p:nvSpPr>
+        <p:spPr>
+          <a:xfrm>
+            <a:off x="624830" y="2861575"/>
+            <a:ext cx="3715054" cy="222647"/>
+          </a:xfrm>
+          <a:prstGeom prst="rect">
+            <a:avLst/>
+          </a:prstGeom>
+          <a:noFill/>
+          <a:ln/>
+        </p:spPr>
+        <p:txBody>
+          <a:bodyPr wrap="none" lIns="0" tIns="0" rIns="0" bIns="0" rtlCol="0" anchor="t"/>
+          <a:lstStyle/>
+          <a:p>
+            <a:pPr marL="0" indent="0" algn="l">
+              <a:lnSpc>
+                <a:spcPct val="104000"/>
+              </a:lnSpc>
+              <a:buNone/>
+            </a:pPr>
+            <a:r>
+              <a:rPr lang="en-US" sz="1400" b="1" dirty="0">
+                <a:solidFill>
+                  <a:srgbClr val="384653"/>
+                </a:solidFill>
+                <a:latin typeface="Barlow Bold" pitchFamily="34" charset="0"/>
+                <a:ea typeface="Barlow Bold" pitchFamily="34" charset="-122"/>
+                <a:cs typeface="Barlow Bold" pitchFamily="34" charset="-120"/>
+              </a:rPr>
+              <a:t>Type-D : Highly Customizable elevators</a:t>
+            </a:r>
+            <a:endParaRPr lang="en-US" sz="1400" dirty="0"/>
+          </a:p>
+        </p:txBody>
+      </p:sp>
+      <p:sp>
+        <p:nvSpPr>
+          <p:cNvPr id="12" name="TextBox 11">
+            <a:extLst>
+              <a:ext uri="{FF2B5EF4-FFF2-40B4-BE49-F238E27FC236}">
+                <a16:creationId xmlns:a16="http://schemas.microsoft.com/office/drawing/2014/main" id="{CFE7DDBD-E3AE-EE59-CF68-24D3719B3BAF}"/>
+              </a:ext>
+            </a:extLst>
+          </p:cNvPr>
+          <p:cNvSpPr txBox="1"/>
+          <p:nvPr/>
+        </p:nvSpPr>
+        <p:spPr>
+          <a:xfrm>
+            <a:off x="485662" y="1568548"/>
+            <a:ext cx="8196114" cy="738664"/>
+          </a:xfrm>
+          <a:prstGeom prst="rect">
+            <a:avLst/>
+          </a:prstGeom>
+          <a:noFill/>
+        </p:spPr>
+        <p:txBody>
+          <a:bodyPr wrap="square" rtlCol="0">
+            <a:spAutoFit/>
+          </a:bodyPr>
+          <a:lstStyle/>
+          <a:p>
+            <a:pPr marL="285750" indent="-285750">
+              <a:buFont typeface="Arial" panose="020B0604020202020204" pitchFamily="34" charset="0"/>
+              <a:buChar char="•"/>
+            </a:pPr>
+            <a:r>
+              <a:rPr lang="en-IN" sz="1400" dirty="0"/>
+              <a:t>Rugged, high-capacity components with industrial-grade fire evacuation and remote monitoring for demanding industrial / commercial environments.</a:t>
+            </a:r>
+          </a:p>
+          <a:p>
+            <a:pPr marL="285750" indent="-285750">
+              <a:buFont typeface="Arial" panose="020B0604020202020204" pitchFamily="34" charset="0"/>
+              <a:buChar char="•"/>
+            </a:pPr>
+            <a:r>
+              <a:rPr lang="en-IN" sz="1400" dirty="0"/>
+              <a:t>Offers various certifications and industrial-grade features for robust industrial level handling.</a:t>
+            </a:r>
+          </a:p>
+        </p:txBody>
+      </p:sp>
+      <p:sp>
+        <p:nvSpPr>
+          <p:cNvPr id="14" name="TextBox 13">
+            <a:extLst>
+              <a:ext uri="{FF2B5EF4-FFF2-40B4-BE49-F238E27FC236}">
+                <a16:creationId xmlns:a16="http://schemas.microsoft.com/office/drawing/2014/main" id="{BF5C1456-278D-04D5-63F7-2B9B6C9CECA5}"/>
+              </a:ext>
+            </a:extLst>
+          </p:cNvPr>
+          <p:cNvSpPr txBox="1"/>
+          <p:nvPr/>
+        </p:nvSpPr>
+        <p:spPr>
+          <a:xfrm>
+            <a:off x="490349" y="3451271"/>
+            <a:ext cx="8196114" cy="954107"/>
+          </a:xfrm>
+          <a:prstGeom prst="rect">
+            <a:avLst/>
+          </a:prstGeom>
+          <a:noFill/>
+        </p:spPr>
+        <p:txBody>
+          <a:bodyPr wrap="square" rtlCol="0">
+            <a:spAutoFit/>
+          </a:bodyPr>
+          <a:lstStyle/>
+          <a:p>
+            <a:pPr marL="285750" indent="-285750">
+              <a:buFont typeface="Arial" panose="020B0604020202020204" pitchFamily="34" charset="0"/>
+              <a:buChar char="•"/>
+            </a:pPr>
+            <a:r>
+              <a:rPr lang="en-IN" sz="1400" dirty="0"/>
+              <a:t>This elevator class is an extension of ‘Type-B’ elevator class offering more feature classes for customers to explore various elevator configurations.</a:t>
+            </a:r>
+          </a:p>
+          <a:p>
+            <a:pPr marL="285750" indent="-285750">
+              <a:buFont typeface="Arial" panose="020B0604020202020204" pitchFamily="34" charset="0"/>
+              <a:buChar char="•"/>
+            </a:pPr>
+            <a:r>
+              <a:rPr lang="en-IN" sz="1400" dirty="0"/>
+              <a:t>Offers 50 customizable feature classes with 37 dependencies/constraints which is kept in check by the rule engine.</a:t>
+            </a:r>
+          </a:p>
+        </p:txBody>
+      </p:sp>
+    </p:spTree>
+    <p:extLst>
+      <p:ext uri="{BB962C8B-B14F-4D97-AF65-F5344CB8AC3E}">
+        <p14:creationId xmlns:p14="http://schemas.microsoft.com/office/powerpoint/2010/main" val="1855165353"/>
+      </p:ext>
+    </p:extLst>
+  </p:cSld>
+  <p:clrMapOvr>
+    <a:masterClrMapping/>
+  </p:clrMapOvr>
+</p:sld>
+</file>
+
+<file path=ppt/slides/slide7.xml><?xml version="1.0" encoding="utf-8"?>
 <p:sld xmlns:a="http://schemas.openxmlformats.org/drawingml/2006/main" xmlns:r="http://schemas.openxmlformats.org/officeDocument/2006/relationships" xmlns:p="http://schemas.openxmlformats.org/presentationml/2006/main">
   <p:cSld name="Slide 8">
     <p:spTree>
@@ -5695,7 +6380,20 @@
                 <a:effectLst/>
                 <a:latin typeface="Montserrat Medium" panose="00000600000000000000" pitchFamily="2" charset="0"/>
               </a:rPr>
-              <a:t> intuitive React UI and instantly validates them against strict physical constraints using our custom Rule Engine.</a:t>
+              <a:t> intuitive React UI and instantly validates them against strict physical constraints using </a:t>
+            </a:r>
+            <a:r>
+              <a:rPr lang="en-IN" sz="1000" dirty="0">
+                <a:latin typeface="Montserrat Medium" panose="00000600000000000000" pitchFamily="2" charset="0"/>
+              </a:rPr>
+              <a:t>the</a:t>
+            </a:r>
+            <a:r>
+              <a:rPr lang="en-IN" sz="1000" b="0" i="0" dirty="0">
+                <a:effectLst/>
+                <a:latin typeface="Montserrat Medium" panose="00000600000000000000" pitchFamily="2" charset="0"/>
+              </a:rPr>
+              <a:t> custom Rule Engine.</a:t>
             </a:r>
           </a:p>
           <a:p>
@@ -5832,7 +6530,7 @@
 </p:sld>
 </file>
 
-<file path=ppt/slides/slide6.xml><?xml version="1.0" encoding="utf-8"?>
+<file path=ppt/slides/slide8.xml><?xml version="1.0" encoding="utf-8"?>
 <p:sld xmlns:a="http://schemas.openxmlformats.org/drawingml/2006/main" xmlns:r="http://schemas.openxmlformats.org/officeDocument/2006/relationships" xmlns:p="http://schemas.openxmlformats.org/presentationml/2006/main">
   <p:cSld name="Slide 6">
     <p:spTree>
@@ -6423,7 +7121,7 @@
 </p:sld>
 </file>
 
-<file path=ppt/slides/slide7.xml><?xml version="1.0" encoding="utf-8"?>
+<file path=ppt/slides/slide9.xml><?xml version="1.0" encoding="utf-8"?>
 <p:sld xmlns:a="http://schemas.openxmlformats.org/drawingml/2006/main" xmlns:r="http://schemas.openxmlformats.org/officeDocument/2006/relationships" xmlns:p="http://schemas.openxmlformats.org/presentationml/2006/main">
   <p:cSld name="Slide 10">
     <p:spTree>

</xml_diff>